<commit_message>
chore: refine architecture slide
Signed-off-by: Gabriele Rossini <103837052+gabrosys@users.noreply.github.com>
</commit_message>
<xml_diff>
--- a/slides/pg-unified-o11y.pptx
+++ b/slides/pg-unified-o11y.pptx
@@ -5173,74 +5173,259 @@
           </a:p>
         </p:txBody>
       </p:sp>
-      <p:sp>
-        <p:nvSpPr>
-          <p:cNvPr id="5" name="TextBox 4"/>
+      <p:cxnSp>
+        <p:nvCxnSpPr>
+          <p:cNvPr id="23" name="Connector 22"/>
+          <p:cNvCxnSpPr/>
+          <p:nvPr/>
+        </p:nvCxnSpPr>
+        <p:spPr>
+          <a:xfrm>
+            <a:off x="365760" y="5440680"/>
+            <a:ext cx="11460175" cy="0"/>
+          </a:xfrm>
+          <a:prstGeom prst="line">
+            <a:avLst/>
+          </a:prstGeom>
+          <a:ln w="12700">
+            <a:solidFill>
+              <a:srgbClr val="A8C2CA"/>
+            </a:solidFill>
+          </a:ln>
+          <a:effectLst/>
+        </p:spPr>
+        <p:style>
+          <a:lnRef idx="2">
+            <a:schemeClr val="accent1"/>
+          </a:lnRef>
+          <a:fillRef idx="0">
+            <a:schemeClr val="accent1"/>
+          </a:fillRef>
+          <a:effectRef idx="1">
+            <a:schemeClr val="accent1"/>
+          </a:effectRef>
+          <a:fontRef idx="minor">
+            <a:schemeClr val="tx1"/>
+          </a:fontRef>
+        </p:style>
+      </p:cxnSp>
+      <p:sp>
+        <p:nvSpPr>
+          <p:cNvPr id="24" name="TextBox 23"/>
+          <p:cNvSpPr txBox="1"/>
+          <p:nvPr/>
+        </p:nvSpPr>
+        <p:spPr>
+          <a:xfrm>
+            <a:off x="365760" y="5559552"/>
+            <a:ext cx="5501487" cy="566928"/>
+          </a:xfrm>
+          <a:prstGeom prst="rect">
+            <a:avLst/>
+          </a:prstGeom>
+          <a:noFill/>
+        </p:spPr>
+        <p:txBody>
+          <a:bodyPr wrap="square" anchor="t" lIns="0" rIns="0" tIns="0" bIns="0">
+            <a:spAutoFit/>
+          </a:bodyPr>
+          <a:lstStyle/>
+          <a:p>
+            <a:pPr algn="l">
+              <a:lnSpc>
+                <a:spcPct val="100000"/>
+              </a:lnSpc>
+            </a:pPr>
+            <a:r>
+              <a:rPr sz="1300" b="0" i="0">
+                <a:solidFill>
+                  <a:srgbClr val="28495A"/>
+                </a:solidFill>
+                <a:latin typeface="Roboto"/>
+              </a:rPr>
+              <a:t>Traces and both log streams join on query_id.</a:t>
+            </a:r>
+          </a:p>
+          <a:p>
+            <a:pPr algn="l">
+              <a:lnSpc>
+                <a:spcPct val="100000"/>
+              </a:lnSpc>
+            </a:pPr>
+            <a:r>
+              <a:rPr sz="1300" b="0" i="0">
+                <a:solidFill>
+                  <a:srgbClr val="28495A"/>
+                </a:solidFill>
+                <a:latin typeface="Roboto"/>
+              </a:rPr>
+              <a:t>Metrics join by time and pod name.</a:t>
+            </a:r>
+          </a:p>
+        </p:txBody>
+      </p:sp>
+      <p:sp>
+        <p:nvSpPr>
+          <p:cNvPr id="25" name="TextBox 24"/>
+          <p:cNvSpPr txBox="1"/>
+          <p:nvPr/>
+        </p:nvSpPr>
+        <p:spPr>
+          <a:xfrm>
+            <a:off x="6324447" y="5559552"/>
+            <a:ext cx="5501487" cy="566928"/>
+          </a:xfrm>
+          <a:prstGeom prst="rect">
+            <a:avLst/>
+          </a:prstGeom>
+          <a:noFill/>
+        </p:spPr>
+        <p:txBody>
+          <a:bodyPr wrap="square" anchor="t" lIns="0" rIns="0" tIns="0" bIns="0">
+            <a:spAutoFit/>
+          </a:bodyPr>
+          <a:lstStyle/>
+          <a:p>
+            <a:pPr algn="l">
+              <a:lnSpc>
+                <a:spcPct val="100000"/>
+              </a:lnSpc>
+            </a:pPr>
+            <a:r>
+              <a:rPr sz="1300" b="0" i="0">
+                <a:solidFill>
+                  <a:srgbClr val="28495A"/>
+                </a:solidFill>
+                <a:latin typeface="Roboto"/>
+              </a:rPr>
+              <a:t>Why ClickHouse: columnar, cheap to keep, fast to query.</a:t>
+            </a:r>
+          </a:p>
+        </p:txBody>
+      </p:sp>
+      <p:pic>
+        <p:nvPicPr>
+          <p:cNvPr id="26" name="Picture 25" descr="edb_postgres_ai_lightmode.png"/>
+          <p:cNvPicPr>
+            <a:picLocks noChangeAspect="1"/>
+          </p:cNvPicPr>
+          <p:nvPr/>
+        </p:nvPicPr>
+        <p:blipFill>
+          <a:blip r:embed="rId2"/>
+          <a:stretch>
+            <a:fillRect/>
+          </a:stretch>
+        </p:blipFill>
+        <p:spPr>
+          <a:xfrm>
+            <a:off x="256032" y="6419088"/>
+            <a:ext cx="877824" cy="201168"/>
+          </a:xfrm>
+          <a:prstGeom prst="rect">
+            <a:avLst/>
+          </a:prstGeom>
+        </p:spPr>
+      </p:pic>
+      <p:sp>
+        <p:nvSpPr>
+          <p:cNvPr id="27" name="TextBox 26"/>
+          <p:cNvSpPr txBox="1"/>
+          <p:nvPr/>
+        </p:nvSpPr>
+        <p:spPr>
+          <a:xfrm>
+            <a:off x="8259775" y="6437376"/>
+            <a:ext cx="3657600" cy="182880"/>
+          </a:xfrm>
+          <a:prstGeom prst="rect">
+            <a:avLst/>
+          </a:prstGeom>
+          <a:noFill/>
+        </p:spPr>
+        <p:txBody>
+          <a:bodyPr wrap="square" anchor="t" lIns="0" rIns="0" tIns="0" bIns="0">
+            <a:spAutoFit/>
+          </a:bodyPr>
+          <a:lstStyle/>
+          <a:p>
+            <a:pPr algn="r">
+              <a:lnSpc>
+                <a:spcPct val="100000"/>
+              </a:lnSpc>
+            </a:pPr>
+            <a:r>
+              <a:rPr sz="750" b="0" i="0">
+                <a:solidFill>
+                  <a:srgbClr val="567F8D"/>
+                </a:solidFill>
+                <a:latin typeface="Roboto"/>
+              </a:rPr>
+              <a:t>©EDB 2026 — ALL RIGHTS RESERVED.</a:t>
+            </a:r>
+          </a:p>
+        </p:txBody>
+      </p:sp>
+      <p:sp>
+        <p:nvSpPr>
+          <p:cNvPr id="28" name="TextBox 27"/>
           <p:cNvSpPr txBox="1"/>
           <p:nvPr/>
         </p:nvSpPr>
         <p:spPr>
           <a:xfrm>
             <a:off x="365760" y="1536192"/>
-            <a:ext cx="2487853" cy="219456"/>
-          </a:xfrm>
-          <a:prstGeom prst="rect">
-            <a:avLst/>
-          </a:prstGeom>
-          <a:noFill/>
-        </p:spPr>
-        <p:txBody>
-          <a:bodyPr wrap="square" anchor="t" lIns="0" rIns="0" tIns="0" bIns="0">
-            <a:spAutoFit/>
-          </a:bodyPr>
-          <a:lstStyle/>
-          <a:p>
-            <a:pPr algn="l">
-              <a:lnSpc>
-                <a:spcPct val="100000"/>
-              </a:lnSpc>
-            </a:pPr>
-            <a:r>
-              <a:rPr sz="1100" b="1" i="0">
+            <a:ext cx="2286000" cy="219456"/>
+          </a:xfrm>
+          <a:prstGeom prst="rect">
+            <a:avLst/>
+          </a:prstGeom>
+          <a:noFill/>
+        </p:spPr>
+        <p:txBody>
+          <a:bodyPr wrap="square" anchor="t" lIns="0" rIns="0" tIns="0" bIns="0">
+            <a:noAutofit/>
+          </a:bodyPr>
+          <a:lstStyle/>
+          <a:p>
+            <a:pPr algn="l"/>
+            <a:r>
+              <a:rPr sz="1100" b="1">
                 <a:solidFill>
                   <a:srgbClr val="567F8D"/>
                 </a:solidFill>
                 <a:latin typeface="Roboto Condensed"/>
               </a:rPr>
-              <a:t>PER CLUSTER</a:t>
-            </a:r>
-          </a:p>
-        </p:txBody>
-      </p:sp>
-      <p:sp>
-        <p:nvSpPr>
-          <p:cNvPr id="6" name="TextBox 5"/>
-          <p:cNvSpPr txBox="1"/>
-          <p:nvPr/>
-        </p:nvSpPr>
-        <p:spPr>
-          <a:xfrm>
-            <a:off x="3356533" y="1536192"/>
-            <a:ext cx="2487853" cy="219456"/>
-          </a:xfrm>
-          <a:prstGeom prst="rect">
-            <a:avLst/>
-          </a:prstGeom>
-          <a:noFill/>
-        </p:spPr>
-        <p:txBody>
-          <a:bodyPr wrap="square" anchor="t" lIns="0" rIns="0" tIns="0" bIns="0">
-            <a:spAutoFit/>
-          </a:bodyPr>
-          <a:lstStyle/>
-          <a:p>
-            <a:pPr algn="l">
-              <a:lnSpc>
-                <a:spcPct val="100000"/>
-              </a:lnSpc>
-            </a:pPr>
-            <a:r>
-              <a:rPr sz="1100" b="1" i="0">
+              <a:t>POSTGRESQL INSTANCES</a:t>
+            </a:r>
+          </a:p>
+        </p:txBody>
+      </p:sp>
+      <p:sp>
+        <p:nvSpPr>
+          <p:cNvPr id="29" name="TextBox 28"/>
+          <p:cNvSpPr txBox="1"/>
+          <p:nvPr/>
+        </p:nvSpPr>
+        <p:spPr>
+          <a:xfrm>
+            <a:off x="3419856" y="1536192"/>
+            <a:ext cx="2286000" cy="219456"/>
+          </a:xfrm>
+          <a:prstGeom prst="rect">
+            <a:avLst/>
+          </a:prstGeom>
+          <a:noFill/>
+        </p:spPr>
+        <p:txBody>
+          <a:bodyPr wrap="square" anchor="t" lIns="0" rIns="0" tIns="0" bIns="0">
+            <a:noAutofit/>
+          </a:bodyPr>
+          <a:lstStyle/>
+          <a:p>
+            <a:pPr algn="l"/>
+            <a:r>
+              <a:rPr sz="1100" b="1">
                 <a:solidFill>
                   <a:srgbClr val="567F8D"/>
                 </a:solidFill>
@@ -5253,33 +5438,29 @@
       </p:sp>
       <p:sp>
         <p:nvSpPr>
-          <p:cNvPr id="7" name="TextBox 6"/>
-          <p:cNvSpPr txBox="1"/>
-          <p:nvPr/>
-        </p:nvSpPr>
-        <p:spPr>
-          <a:xfrm>
-            <a:off x="6347307" y="1536192"/>
-            <a:ext cx="2487853" cy="219456"/>
-          </a:xfrm>
-          <a:prstGeom prst="rect">
-            <a:avLst/>
-          </a:prstGeom>
-          <a:noFill/>
-        </p:spPr>
-        <p:txBody>
-          <a:bodyPr wrap="square" anchor="t" lIns="0" rIns="0" tIns="0" bIns="0">
-            <a:spAutoFit/>
-          </a:bodyPr>
-          <a:lstStyle/>
-          <a:p>
-            <a:pPr algn="l">
-              <a:lnSpc>
-                <a:spcPct val="100000"/>
-              </a:lnSpc>
-            </a:pPr>
-            <a:r>
-              <a:rPr sz="1100" b="1" i="0">
+          <p:cNvPr id="30" name="TextBox 29"/>
+          <p:cNvSpPr txBox="1"/>
+          <p:nvPr/>
+        </p:nvSpPr>
+        <p:spPr>
+          <a:xfrm>
+            <a:off x="6473952" y="1536192"/>
+            <a:ext cx="2286000" cy="219456"/>
+          </a:xfrm>
+          <a:prstGeom prst="rect">
+            <a:avLst/>
+          </a:prstGeom>
+          <a:noFill/>
+        </p:spPr>
+        <p:txBody>
+          <a:bodyPr wrap="square" anchor="t" lIns="0" rIns="0" tIns="0" bIns="0">
+            <a:noAutofit/>
+          </a:bodyPr>
+          <a:lstStyle/>
+          <a:p>
+            <a:pPr algn="l"/>
+            <a:r>
+              <a:rPr sz="1100" b="1">
                 <a:solidFill>
                   <a:srgbClr val="567F8D"/>
                 </a:solidFill>
@@ -5292,33 +5473,29 @@
       </p:sp>
       <p:sp>
         <p:nvSpPr>
-          <p:cNvPr id="8" name="TextBox 7"/>
-          <p:cNvSpPr txBox="1"/>
-          <p:nvPr/>
-        </p:nvSpPr>
-        <p:spPr>
-          <a:xfrm>
-            <a:off x="9338081" y="1536192"/>
-            <a:ext cx="2487853" cy="219456"/>
-          </a:xfrm>
-          <a:prstGeom prst="rect">
-            <a:avLst/>
-          </a:prstGeom>
-          <a:noFill/>
-        </p:spPr>
-        <p:txBody>
-          <a:bodyPr wrap="square" anchor="t" lIns="0" rIns="0" tIns="0" bIns="0">
-            <a:spAutoFit/>
-          </a:bodyPr>
-          <a:lstStyle/>
-          <a:p>
-            <a:pPr algn="l">
-              <a:lnSpc>
-                <a:spcPct val="100000"/>
-              </a:lnSpc>
-            </a:pPr>
-            <a:r>
-              <a:rPr sz="1100" b="1" i="0">
+          <p:cNvPr id="31" name="TextBox 30"/>
+          <p:cNvSpPr txBox="1"/>
+          <p:nvPr/>
+        </p:nvSpPr>
+        <p:spPr>
+          <a:xfrm>
+            <a:off x="9528048" y="1536192"/>
+            <a:ext cx="2286000" cy="219456"/>
+          </a:xfrm>
+          <a:prstGeom prst="rect">
+            <a:avLst/>
+          </a:prstGeom>
+          <a:noFill/>
+        </p:spPr>
+        <p:txBody>
+          <a:bodyPr wrap="square" anchor="t" lIns="0" rIns="0" tIns="0" bIns="0">
+            <a:noAutofit/>
+          </a:bodyPr>
+          <a:lstStyle/>
+          <a:p>
+            <a:pPr algn="l"/>
+            <a:r>
+              <a:rPr sz="1100" b="1">
                 <a:solidFill>
                   <a:srgbClr val="567F8D"/>
                 </a:solidFill>
@@ -5331,18 +5508,64 @@
       </p:sp>
       <p:sp>
         <p:nvSpPr>
-          <p:cNvPr id="9" name="Rounded Rectangle 8"/>
+          <p:cNvPr id="32" name="Instance frame"/>
           <p:cNvSpPr/>
           <p:nvPr/>
         </p:nvSpPr>
         <p:spPr>
           <a:xfrm>
-            <a:off x="365760" y="1874519"/>
-            <a:ext cx="2487853" cy="868680"/>
+            <a:off x="365760" y="1828800"/>
+            <a:ext cx="2286000" cy="3255264"/>
           </a:xfrm>
           <a:prstGeom prst="roundRect">
             <a:avLst>
-              <a:gd name="adj" fmla="val 5424"/>
+              <a:gd name="adj" fmla="val 3000"/>
+            </a:avLst>
+          </a:prstGeom>
+          <a:noFill/>
+          <a:ln w="12700">
+            <a:solidFill>
+              <a:srgbClr val="A8C2CA"/>
+            </a:solidFill>
+          </a:ln>
+          <a:effectLst/>
+        </p:spPr>
+        <p:style>
+          <a:lnRef idx="1">
+            <a:schemeClr val="accent1"/>
+          </a:lnRef>
+          <a:fillRef idx="3">
+            <a:schemeClr val="accent1"/>
+          </a:fillRef>
+          <a:effectRef idx="2">
+            <a:schemeClr val="accent1"/>
+          </a:effectRef>
+          <a:fontRef idx="minor">
+            <a:schemeClr val="lt1"/>
+          </a:fontRef>
+        </p:style>
+        <p:txBody>
+          <a:bodyPr rtlCol="0" anchor="ctr"/>
+          <a:lstStyle/>
+          <a:p>
+            <a:pPr algn="ctr"/>
+          </a:p>
+        </p:txBody>
+      </p:sp>
+      <p:sp>
+        <p:nvSpPr>
+          <p:cNvPr id="33" name="Rounded Rectangle 32"/>
+          <p:cNvSpPr/>
+          <p:nvPr/>
+        </p:nvSpPr>
+        <p:spPr>
+          <a:xfrm>
+            <a:off x="475488" y="1938528"/>
+            <a:ext cx="2066543" cy="676656"/>
+          </a:xfrm>
+          <a:prstGeom prst="roundRect">
+            <a:avLst>
+              <a:gd name="adj" fmla="val 5400"/>
             </a:avLst>
           </a:prstGeom>
           <a:solidFill>
@@ -5385,31 +5608,31 @@
           <a:p>
             <a:pPr algn="ctr"/>
             <a:r>
-              <a:rPr sz="1200">
+              <a:rPr sz="1200" b="0">
                 <a:solidFill>
                   <a:srgbClr val="567F8D"/>
                 </a:solidFill>
                 <a:latin typeface="Roboto"/>
               </a:rPr>
-              <a:t>spans</a:t>
-            </a:r>
-          </a:p>
-        </p:txBody>
-      </p:sp>
-      <p:sp>
-        <p:nvSpPr>
-          <p:cNvPr id="10" name="Rounded Rectangle 9"/>
+              <a:t>query spans</a:t>
+            </a:r>
+          </a:p>
+        </p:txBody>
+      </p:sp>
+      <p:sp>
+        <p:nvSpPr>
+          <p:cNvPr id="34" name="Rounded Rectangle 33"/>
           <p:cNvSpPr/>
           <p:nvPr/>
         </p:nvSpPr>
         <p:spPr>
           <a:xfrm>
-            <a:off x="365760" y="2926079"/>
-            <a:ext cx="2487853" cy="868680"/>
+            <a:off x="475488" y="2724912"/>
+            <a:ext cx="2066543" cy="676656"/>
           </a:xfrm>
           <a:prstGeom prst="roundRect">
             <a:avLst>
-              <a:gd name="adj" fmla="val 5424"/>
+              <a:gd name="adj" fmla="val 5400"/>
             </a:avLst>
           </a:prstGeom>
           <a:solidFill>
@@ -5452,7 +5675,7 @@
           <a:p>
             <a:pPr algn="ctr"/>
             <a:r>
-              <a:rPr sz="1200">
+              <a:rPr sz="1200" b="0">
                 <a:solidFill>
                   <a:srgbClr val="567F8D"/>
                 </a:solidFill>
@@ -5465,18 +5688,18 @@
       </p:sp>
       <p:sp>
         <p:nvSpPr>
-          <p:cNvPr id="11" name="Rounded Rectangle 10"/>
+          <p:cNvPr id="35" name="Rounded Rectangle 34"/>
           <p:cNvSpPr/>
           <p:nvPr/>
         </p:nvSpPr>
         <p:spPr>
           <a:xfrm>
-            <a:off x="365760" y="3977639"/>
-            <a:ext cx="2487853" cy="868680"/>
+            <a:off x="475488" y="3511296"/>
+            <a:ext cx="2066543" cy="676656"/>
           </a:xfrm>
           <a:prstGeom prst="roundRect">
             <a:avLst>
-              <a:gd name="adj" fmla="val 5424"/>
+              <a:gd name="adj" fmla="val 5400"/>
             </a:avLst>
           </a:prstGeom>
           <a:solidFill>
@@ -5513,37 +5736,37 @@
                 </a:solidFill>
                 <a:latin typeface="Roboto Condensed"/>
               </a:rPr>
-              <a:t>Server log</a:t>
+              <a:t>Instance metrics</a:t>
             </a:r>
           </a:p>
           <a:p>
             <a:pPr algn="ctr"/>
             <a:r>
-              <a:rPr sz="1200">
+              <a:rPr sz="1200" b="0">
                 <a:solidFill>
                   <a:srgbClr val="567F8D"/>
                 </a:solidFill>
                 <a:latin typeface="Roboto"/>
               </a:rPr>
-              <a:t>container stdout</a:t>
-            </a:r>
-          </a:p>
-        </p:txBody>
-      </p:sp>
-      <p:sp>
-        <p:nvSpPr>
-          <p:cNvPr id="12" name="Rounded Rectangle 11"/>
+              <a:t>CNPG exporter</a:t>
+            </a:r>
+          </a:p>
+        </p:txBody>
+      </p:sp>
+      <p:sp>
+        <p:nvSpPr>
+          <p:cNvPr id="36" name="Rounded Rectangle 35"/>
           <p:cNvSpPr/>
           <p:nvPr/>
         </p:nvSpPr>
         <p:spPr>
           <a:xfrm>
-            <a:off x="3356533" y="1874519"/>
-            <a:ext cx="2487853" cy="1783080"/>
+            <a:off x="475488" y="4297680"/>
+            <a:ext cx="2066543" cy="676656"/>
           </a:xfrm>
           <a:prstGeom prst="roundRect">
             <a:avLst>
-              <a:gd name="adj" fmla="val 5424"/>
+              <a:gd name="adj" fmla="val 5400"/>
             </a:avLst>
           </a:prstGeom>
           <a:solidFill>
@@ -5580,37 +5803,72 @@
                 </a:solidFill>
                 <a:latin typeface="Roboto Condensed"/>
               </a:rPr>
-              <a:t>OTel gateway</a:t>
+              <a:t>PostgreSQL log</a:t>
             </a:r>
           </a:p>
           <a:p>
             <a:pPr algn="ctr"/>
             <a:r>
-              <a:rPr sz="1200">
+              <a:rPr sz="1200" b="0">
                 <a:solidFill>
                   <a:srgbClr val="567F8D"/>
                 </a:solidFill>
                 <a:latin typeface="Roboto"/>
               </a:rPr>
-              <a:t>OTLP and Prometheus scrape</a:t>
-            </a:r>
-          </a:p>
-        </p:txBody>
-      </p:sp>
-      <p:sp>
-        <p:nvSpPr>
-          <p:cNvPr id="13" name="Rounded Rectangle 12"/>
+              <a:t>stdout of each instance</a:t>
+            </a:r>
+          </a:p>
+        </p:txBody>
+      </p:sp>
+      <p:sp>
+        <p:nvSpPr>
+          <p:cNvPr id="37" name="TextBox 36"/>
+          <p:cNvSpPr txBox="1"/>
+          <p:nvPr/>
+        </p:nvSpPr>
+        <p:spPr>
+          <a:xfrm>
+            <a:off x="365760" y="5157216"/>
+            <a:ext cx="2286000" cy="182880"/>
+          </a:xfrm>
+          <a:prstGeom prst="rect">
+            <a:avLst/>
+          </a:prstGeom>
+          <a:noFill/>
+        </p:spPr>
+        <p:txBody>
+          <a:bodyPr wrap="square" anchor="t" lIns="0" rIns="0" tIns="0" bIns="0">
+            <a:noAutofit/>
+          </a:bodyPr>
+          <a:lstStyle/>
+          <a:p>
+            <a:pPr algn="l"/>
+            <a:r>
+              <a:rPr sz="1100" b="0">
+                <a:solidFill>
+                  <a:srgbClr val="567F8D"/>
+                </a:solidFill>
+                <a:latin typeface="Roboto"/>
+              </a:rPr>
+              <a:t>One namespace per cluster</a:t>
+            </a:r>
+          </a:p>
+        </p:txBody>
+      </p:sp>
+      <p:sp>
+        <p:nvSpPr>
+          <p:cNvPr id="38" name="Rounded Rectangle 37"/>
           <p:cNvSpPr/>
           <p:nvPr/>
         </p:nvSpPr>
         <p:spPr>
           <a:xfrm>
-            <a:off x="3356533" y="3794760"/>
-            <a:ext cx="2487853" cy="1051559"/>
+            <a:off x="3419856" y="1938528"/>
+            <a:ext cx="2286000" cy="2029967"/>
           </a:xfrm>
           <a:prstGeom prst="roundRect">
             <a:avLst>
-              <a:gd name="adj" fmla="val 5424"/>
+              <a:gd name="adj" fmla="val 5400"/>
             </a:avLst>
           </a:prstGeom>
           <a:solidFill>
@@ -5647,37 +5905,104 @@
                 </a:solidFill>
                 <a:latin typeface="Roboto Condensed"/>
               </a:rPr>
-              <a:t>OTel agent</a:t>
+              <a:t>OTel gateway</a:t>
             </a:r>
           </a:p>
           <a:p>
             <a:pPr algn="ctr"/>
             <a:r>
-              <a:rPr sz="1200">
+              <a:rPr sz="1200" b="0">
                 <a:solidFill>
                   <a:srgbClr val="567F8D"/>
                 </a:solidFill>
                 <a:latin typeface="Roboto"/>
               </a:rPr>
-              <a:t>tails server logs</a:t>
-            </a:r>
-          </a:p>
-        </p:txBody>
-      </p:sp>
-      <p:sp>
-        <p:nvSpPr>
-          <p:cNvPr id="14" name="Rounded Rectangle 13"/>
+              <a:t>receives OTLP, scrapes metrics</a:t>
+            </a:r>
+          </a:p>
+        </p:txBody>
+      </p:sp>
+      <p:sp>
+        <p:nvSpPr>
+          <p:cNvPr id="39" name="Rounded Rectangle 38"/>
           <p:cNvSpPr/>
           <p:nvPr/>
         </p:nvSpPr>
         <p:spPr>
           <a:xfrm>
-            <a:off x="6347307" y="1874519"/>
-            <a:ext cx="2487853" cy="2971800"/>
+            <a:off x="3419856" y="4297680"/>
+            <a:ext cx="2286000" cy="676656"/>
           </a:xfrm>
           <a:prstGeom prst="roundRect">
             <a:avLst>
-              <a:gd name="adj" fmla="val 5424"/>
+              <a:gd name="adj" fmla="val 5400"/>
+            </a:avLst>
+          </a:prstGeom>
+          <a:solidFill>
+            <a:srgbClr val="E8F2F5"/>
+          </a:solidFill>
+          <a:ln>
+            <a:noFill/>
+          </a:ln>
+          <a:effectLst/>
+        </p:spPr>
+        <p:style>
+          <a:lnRef idx="1">
+            <a:schemeClr val="accent1"/>
+          </a:lnRef>
+          <a:fillRef idx="3">
+            <a:schemeClr val="accent1"/>
+          </a:fillRef>
+          <a:effectRef idx="2">
+            <a:schemeClr val="accent1"/>
+          </a:effectRef>
+          <a:fontRef idx="minor">
+            <a:schemeClr val="lt1"/>
+          </a:fontRef>
+        </p:style>
+        <p:txBody>
+          <a:bodyPr rtlCol="0" anchor="ctr" wrap="square" lIns="73152" rIns="73152" tIns="36576" bIns="36576"/>
+          <a:lstStyle/>
+          <a:p>
+            <a:pPr algn="ctr"/>
+            <a:r>
+              <a:rPr sz="1500" b="1">
+                <a:solidFill>
+                  <a:srgbClr val="28495A"/>
+                </a:solidFill>
+                <a:latin typeface="Roboto Condensed"/>
+              </a:rPr>
+              <a:t>OTel agent</a:t>
+            </a:r>
+          </a:p>
+          <a:p>
+            <a:pPr algn="ctr"/>
+            <a:r>
+              <a:rPr sz="1200" b="0">
+                <a:solidFill>
+                  <a:srgbClr val="567F8D"/>
+                </a:solidFill>
+                <a:latin typeface="Roboto"/>
+              </a:rPr>
+              <a:t>one per node, tails logs</a:t>
+            </a:r>
+          </a:p>
+        </p:txBody>
+      </p:sp>
+      <p:sp>
+        <p:nvSpPr>
+          <p:cNvPr id="40" name="Rounded Rectangle 39"/>
+          <p:cNvSpPr/>
+          <p:nvPr/>
+        </p:nvSpPr>
+        <p:spPr>
+          <a:xfrm>
+            <a:off x="6473952" y="1938528"/>
+            <a:ext cx="2286000" cy="3035808"/>
+          </a:xfrm>
+          <a:prstGeom prst="roundRect">
+            <a:avLst>
+              <a:gd name="adj" fmla="val 5400"/>
             </a:avLst>
           </a:prstGeom>
           <a:solidFill>
@@ -5720,7 +6045,7 @@
           <a:p>
             <a:pPr algn="ctr"/>
             <a:r>
-              <a:rPr sz="1900">
+              <a:rPr sz="1900" b="0">
                 <a:solidFill>
                   <a:srgbClr val="A8C2CA"/>
                 </a:solidFill>
@@ -5733,18 +6058,18 @@
       </p:sp>
       <p:sp>
         <p:nvSpPr>
-          <p:cNvPr id="15" name="Rounded Rectangle 14"/>
+          <p:cNvPr id="41" name="Rounded Rectangle 40"/>
           <p:cNvSpPr/>
           <p:nvPr/>
         </p:nvSpPr>
         <p:spPr>
           <a:xfrm>
-            <a:off x="9338081" y="1874519"/>
-            <a:ext cx="2487853" cy="2971800"/>
+            <a:off x="9528048" y="1938528"/>
+            <a:ext cx="2286000" cy="3035808"/>
           </a:xfrm>
           <a:prstGeom prst="roundRect">
             <a:avLst>
-              <a:gd name="adj" fmla="val 5424"/>
+              <a:gd name="adj" fmla="val 5400"/>
             </a:avLst>
           </a:prstGeom>
           <a:solidFill>
@@ -5787,7 +6112,7 @@
           <a:p>
             <a:pPr algn="ctr"/>
             <a:r>
-              <a:rPr sz="1900">
+              <a:rPr sz="1900" b="0">
                 <a:solidFill>
                   <a:srgbClr val="A8C2CA"/>
                 </a:solidFill>
@@ -5800,14 +6125,14 @@
       </p:sp>
       <p:cxnSp>
         <p:nvCxnSpPr>
-          <p:cNvPr id="16" name="Connector 15"/>
+          <p:cNvPr id="42" name="Connector 41"/>
           <p:cNvCxnSpPr/>
           <p:nvPr/>
         </p:nvCxnSpPr>
         <p:spPr>
           <a:xfrm>
-            <a:off x="2890189" y="2308860"/>
-            <a:ext cx="429768" cy="0"/>
+            <a:off x="2542032" y="2276856"/>
+            <a:ext cx="877824" cy="0"/>
           </a:xfrm>
           <a:prstGeom prst="line">
             <a:avLst/>
@@ -5835,16 +6160,51 @@
           </a:fontRef>
         </p:style>
       </p:cxnSp>
+      <p:sp>
+        <p:nvSpPr>
+          <p:cNvPr id="43" name="TextBox 42"/>
+          <p:cNvSpPr txBox="1"/>
+          <p:nvPr/>
+        </p:nvSpPr>
+        <p:spPr>
+          <a:xfrm>
+            <a:off x="2651760" y="2075688"/>
+            <a:ext cx="768096" cy="164592"/>
+          </a:xfrm>
+          <a:prstGeom prst="rect">
+            <a:avLst/>
+          </a:prstGeom>
+          <a:noFill/>
+        </p:spPr>
+        <p:txBody>
+          <a:bodyPr wrap="square" anchor="t" lIns="0" rIns="0" tIns="0" bIns="0">
+            <a:noAutofit/>
+          </a:bodyPr>
+          <a:lstStyle/>
+          <a:p>
+            <a:pPr algn="ctr"/>
+            <a:r>
+              <a:rPr sz="1000" b="0">
+                <a:solidFill>
+                  <a:srgbClr val="567F8D"/>
+                </a:solidFill>
+                <a:latin typeface="Roboto"/>
+              </a:rPr>
+              <a:t>OTLP/HTTP</a:t>
+            </a:r>
+          </a:p>
+        </p:txBody>
+      </p:sp>
       <p:cxnSp>
         <p:nvCxnSpPr>
-          <p:cNvPr id="17" name="Connector 16"/>
+          <p:cNvPr id="44" name="Connector 43"/>
           <p:cNvCxnSpPr/>
           <p:nvPr/>
         </p:nvCxnSpPr>
         <p:spPr>
           <a:xfrm>
-            <a:off x="2890189" y="3360420"/>
-            <a:ext cx="429768" cy="0"/>
+            <a:off x="2542032" y="3063240"/>
+            <a:ext cx="877824" cy="0"/>
           </a:xfrm>
           <a:prstGeom prst="line">
             <a:avLst/>
@@ -5872,16 +6232,197 @@
           </a:fontRef>
         </p:style>
       </p:cxnSp>
+      <p:sp>
+        <p:nvSpPr>
+          <p:cNvPr id="45" name="TextBox 44"/>
+          <p:cNvSpPr txBox="1"/>
+          <p:nvPr/>
+        </p:nvSpPr>
+        <p:spPr>
+          <a:xfrm>
+            <a:off x="2651760" y="2862072"/>
+            <a:ext cx="768096" cy="164592"/>
+          </a:xfrm>
+          <a:prstGeom prst="rect">
+            <a:avLst/>
+          </a:prstGeom>
+          <a:noFill/>
+        </p:spPr>
+        <p:txBody>
+          <a:bodyPr wrap="square" anchor="t" lIns="0" rIns="0" tIns="0" bIns="0">
+            <a:noAutofit/>
+          </a:bodyPr>
+          <a:lstStyle/>
+          <a:p>
+            <a:pPr algn="ctr"/>
+            <a:r>
+              <a:rPr sz="1000" b="0">
+                <a:solidFill>
+                  <a:srgbClr val="567F8D"/>
+                </a:solidFill>
+                <a:latin typeface="Roboto"/>
+              </a:rPr>
+              <a:t>OTLP/gRPC</a:t>
+            </a:r>
+          </a:p>
+        </p:txBody>
+      </p:sp>
       <p:cxnSp>
         <p:nvCxnSpPr>
-          <p:cNvPr id="18" name="Connector 17"/>
+          <p:cNvPr id="46" name="Connector 45"/>
           <p:cNvCxnSpPr/>
           <p:nvPr/>
         </p:nvCxnSpPr>
         <p:spPr>
           <a:xfrm>
-            <a:off x="2890189" y="4411979"/>
-            <a:ext cx="429768" cy="0"/>
+            <a:off x="2542032" y="3849624"/>
+            <a:ext cx="877824" cy="0"/>
+          </a:xfrm>
+          <a:prstGeom prst="line">
+            <a:avLst/>
+          </a:prstGeom>
+          <a:ln w="15875">
+            <a:solidFill>
+              <a:srgbClr val="567F8D"/>
+            </a:solidFill>
+            <a:prstDash val="dash"/>
+            <a:tailEnd type="triangle"/>
+          </a:ln>
+          <a:effectLst/>
+        </p:spPr>
+        <p:style>
+          <a:lnRef idx="2">
+            <a:schemeClr val="accent1"/>
+          </a:lnRef>
+          <a:fillRef idx="0">
+            <a:schemeClr val="accent1"/>
+          </a:fillRef>
+          <a:effectRef idx="1">
+            <a:schemeClr val="accent1"/>
+          </a:effectRef>
+          <a:fontRef idx="minor">
+            <a:schemeClr val="tx1"/>
+          </a:fontRef>
+        </p:style>
+      </p:cxnSp>
+      <p:sp>
+        <p:nvSpPr>
+          <p:cNvPr id="47" name="TextBox 46"/>
+          <p:cNvSpPr txBox="1"/>
+          <p:nvPr/>
+        </p:nvSpPr>
+        <p:spPr>
+          <a:xfrm>
+            <a:off x="2651760" y="3648456"/>
+            <a:ext cx="768096" cy="164592"/>
+          </a:xfrm>
+          <a:prstGeom prst="rect">
+            <a:avLst/>
+          </a:prstGeom>
+          <a:noFill/>
+        </p:spPr>
+        <p:txBody>
+          <a:bodyPr wrap="square" anchor="t" lIns="0" rIns="0" tIns="0" bIns="0">
+            <a:noAutofit/>
+          </a:bodyPr>
+          <a:lstStyle/>
+          <a:p>
+            <a:pPr algn="ctr"/>
+            <a:r>
+              <a:rPr sz="1000" b="0">
+                <a:solidFill>
+                  <a:srgbClr val="567F8D"/>
+                </a:solidFill>
+                <a:latin typeface="Roboto"/>
+              </a:rPr>
+              <a:t>scrape</a:t>
+            </a:r>
+          </a:p>
+        </p:txBody>
+      </p:sp>
+      <p:cxnSp>
+        <p:nvCxnSpPr>
+          <p:cNvPr id="48" name="Connector 47"/>
+          <p:cNvCxnSpPr/>
+          <p:nvPr/>
+        </p:nvCxnSpPr>
+        <p:spPr>
+          <a:xfrm>
+            <a:off x="2542032" y="4636008"/>
+            <a:ext cx="877824" cy="0"/>
+          </a:xfrm>
+          <a:prstGeom prst="line">
+            <a:avLst/>
+          </a:prstGeom>
+          <a:ln w="15875">
+            <a:solidFill>
+              <a:srgbClr val="567F8D"/>
+            </a:solidFill>
+            <a:prstDash val="dash"/>
+            <a:tailEnd type="triangle"/>
+          </a:ln>
+          <a:effectLst/>
+        </p:spPr>
+        <p:style>
+          <a:lnRef idx="2">
+            <a:schemeClr val="accent1"/>
+          </a:lnRef>
+          <a:fillRef idx="0">
+            <a:schemeClr val="accent1"/>
+          </a:fillRef>
+          <a:effectRef idx="1">
+            <a:schemeClr val="accent1"/>
+          </a:effectRef>
+          <a:fontRef idx="minor">
+            <a:schemeClr val="tx1"/>
+          </a:fontRef>
+        </p:style>
+      </p:cxnSp>
+      <p:sp>
+        <p:nvSpPr>
+          <p:cNvPr id="49" name="TextBox 48"/>
+          <p:cNvSpPr txBox="1"/>
+          <p:nvPr/>
+        </p:nvSpPr>
+        <p:spPr>
+          <a:xfrm>
+            <a:off x="2651760" y="4434840"/>
+            <a:ext cx="768096" cy="164592"/>
+          </a:xfrm>
+          <a:prstGeom prst="rect">
+            <a:avLst/>
+          </a:prstGeom>
+          <a:noFill/>
+        </p:spPr>
+        <p:txBody>
+          <a:bodyPr wrap="square" anchor="t" lIns="0" rIns="0" tIns="0" bIns="0">
+            <a:noAutofit/>
+          </a:bodyPr>
+          <a:lstStyle/>
+          <a:p>
+            <a:pPr algn="ctr"/>
+            <a:r>
+              <a:rPr sz="1000" b="0">
+                <a:solidFill>
+                  <a:srgbClr val="567F8D"/>
+                </a:solidFill>
+                <a:latin typeface="Roboto"/>
+              </a:rPr>
+              <a:t>file tail</a:t>
+            </a:r>
+          </a:p>
+        </p:txBody>
+      </p:sp>
+      <p:cxnSp>
+        <p:nvCxnSpPr>
+          <p:cNvPr id="50" name="Connector 49"/>
+          <p:cNvCxnSpPr/>
+          <p:nvPr/>
+        </p:nvCxnSpPr>
+        <p:spPr>
+          <a:xfrm flipV="1">
+            <a:off x="4562856" y="3968496"/>
+            <a:ext cx="0" cy="329184"/>
           </a:xfrm>
           <a:prstGeom prst="line">
             <a:avLst/>
@@ -5909,16 +6450,51 @@
           </a:fontRef>
         </p:style>
       </p:cxnSp>
+      <p:sp>
+        <p:nvSpPr>
+          <p:cNvPr id="51" name="TextBox 50"/>
+          <p:cNvSpPr txBox="1"/>
+          <p:nvPr/>
+        </p:nvSpPr>
+        <p:spPr>
+          <a:xfrm>
+            <a:off x="4654296" y="4050791"/>
+            <a:ext cx="914400" cy="164592"/>
+          </a:xfrm>
+          <a:prstGeom prst="rect">
+            <a:avLst/>
+          </a:prstGeom>
+          <a:noFill/>
+        </p:spPr>
+        <p:txBody>
+          <a:bodyPr wrap="square" anchor="t" lIns="0" rIns="0" tIns="0" bIns="0">
+            <a:noAutofit/>
+          </a:bodyPr>
+          <a:lstStyle/>
+          <a:p>
+            <a:pPr algn="l"/>
+            <a:r>
+              <a:rPr sz="1000" b="0">
+                <a:solidFill>
+                  <a:srgbClr val="567F8D"/>
+                </a:solidFill>
+                <a:latin typeface="Roboto"/>
+              </a:rPr>
+              <a:t>OTLP/gRPC</a:t>
+            </a:r>
+          </a:p>
+        </p:txBody>
+      </p:sp>
       <p:cxnSp>
         <p:nvCxnSpPr>
-          <p:cNvPr id="19" name="Connector 18"/>
+          <p:cNvPr id="52" name="Connector 51"/>
           <p:cNvCxnSpPr/>
           <p:nvPr/>
         </p:nvCxnSpPr>
         <p:spPr>
           <a:xfrm>
-            <a:off x="5880963" y="2766060"/>
-            <a:ext cx="429768" cy="0"/>
+            <a:off x="5705856" y="2953512"/>
+            <a:ext cx="768096" cy="0"/>
           </a:xfrm>
           <a:prstGeom prst="line">
             <a:avLst/>
@@ -5946,16 +6522,51 @@
           </a:fontRef>
         </p:style>
       </p:cxnSp>
+      <p:sp>
+        <p:nvSpPr>
+          <p:cNvPr id="53" name="TextBox 52"/>
+          <p:cNvSpPr txBox="1"/>
+          <p:nvPr/>
+        </p:nvSpPr>
+        <p:spPr>
+          <a:xfrm>
+            <a:off x="5705856" y="2752344"/>
+            <a:ext cx="768096" cy="164592"/>
+          </a:xfrm>
+          <a:prstGeom prst="rect">
+            <a:avLst/>
+          </a:prstGeom>
+          <a:noFill/>
+        </p:spPr>
+        <p:txBody>
+          <a:bodyPr wrap="square" anchor="t" lIns="0" rIns="0" tIns="0" bIns="0">
+            <a:noAutofit/>
+          </a:bodyPr>
+          <a:lstStyle/>
+          <a:p>
+            <a:pPr algn="ctr"/>
+            <a:r>
+              <a:rPr sz="1000" b="0">
+                <a:solidFill>
+                  <a:srgbClr val="567F8D"/>
+                </a:solidFill>
+                <a:latin typeface="Roboto"/>
+              </a:rPr>
+              <a:t>insert</a:t>
+            </a:r>
+          </a:p>
+        </p:txBody>
+      </p:sp>
       <p:cxnSp>
         <p:nvCxnSpPr>
-          <p:cNvPr id="20" name="Connector 19"/>
+          <p:cNvPr id="54" name="Connector 53"/>
           <p:cNvCxnSpPr/>
           <p:nvPr/>
         </p:nvCxnSpPr>
         <p:spPr>
           <a:xfrm>
-            <a:off x="5880963" y="4320540"/>
-            <a:ext cx="429768" cy="0"/>
+            <a:off x="8759952" y="3456432"/>
+            <a:ext cx="768096" cy="0"/>
           </a:xfrm>
           <a:prstGeom prst="line">
             <a:avLst/>
@@ -5983,255 +6594,37 @@
           </a:fontRef>
         </p:style>
       </p:cxnSp>
-      <p:cxnSp>
-        <p:nvCxnSpPr>
-          <p:cNvPr id="21" name="Connector 20"/>
-          <p:cNvCxnSpPr/>
-          <p:nvPr/>
-        </p:nvCxnSpPr>
-        <p:spPr>
-          <a:xfrm>
-            <a:off x="8871737" y="3360420"/>
-            <a:ext cx="429768" cy="0"/>
-          </a:xfrm>
-          <a:prstGeom prst="line">
-            <a:avLst/>
-          </a:prstGeom>
-          <a:ln w="15875">
-            <a:solidFill>
-              <a:srgbClr val="567F8D"/>
-            </a:solidFill>
-            <a:tailEnd type="triangle"/>
-          </a:ln>
-          <a:effectLst/>
-        </p:spPr>
-        <p:style>
-          <a:lnRef idx="2">
-            <a:schemeClr val="accent1"/>
-          </a:lnRef>
-          <a:fillRef idx="0">
-            <a:schemeClr val="accent1"/>
-          </a:fillRef>
-          <a:effectRef idx="1">
-            <a:schemeClr val="accent1"/>
-          </a:effectRef>
-          <a:fontRef idx="minor">
-            <a:schemeClr val="tx1"/>
-          </a:fontRef>
-        </p:style>
-      </p:cxnSp>
-      <p:sp>
-        <p:nvSpPr>
-          <p:cNvPr id="22" name="TextBox 21"/>
-          <p:cNvSpPr txBox="1"/>
-          <p:nvPr/>
-        </p:nvSpPr>
-        <p:spPr>
-          <a:xfrm>
-            <a:off x="365760" y="4956048"/>
-            <a:ext cx="2487853" cy="457200"/>
-          </a:xfrm>
-          <a:prstGeom prst="rect">
-            <a:avLst/>
-          </a:prstGeom>
-          <a:noFill/>
-        </p:spPr>
-        <p:txBody>
-          <a:bodyPr wrap="square" anchor="t" lIns="0" rIns="0" tIns="0" bIns="0">
-            <a:spAutoFit/>
-          </a:bodyPr>
-          <a:lstStyle/>
-          <a:p>
-            <a:pPr algn="l">
-              <a:lnSpc>
-                <a:spcPct val="100000"/>
-              </a:lnSpc>
-            </a:pPr>
-            <a:r>
-              <a:rPr sz="1100" b="0" i="0">
+      <p:sp>
+        <p:nvSpPr>
+          <p:cNvPr id="55" name="TextBox 54"/>
+          <p:cNvSpPr txBox="1"/>
+          <p:nvPr/>
+        </p:nvSpPr>
+        <p:spPr>
+          <a:xfrm>
+            <a:off x="8759952" y="3255264"/>
+            <a:ext cx="768096" cy="164592"/>
+          </a:xfrm>
+          <a:prstGeom prst="rect">
+            <a:avLst/>
+          </a:prstGeom>
+          <a:noFill/>
+        </p:spPr>
+        <p:txBody>
+          <a:bodyPr wrap="square" anchor="t" lIns="0" rIns="0" tIns="0" bIns="0">
+            <a:noAutofit/>
+          </a:bodyPr>
+          <a:lstStyle/>
+          <a:p>
+            <a:pPr algn="ctr"/>
+            <a:r>
+              <a:rPr sz="1000" b="0">
                 <a:solidFill>
                   <a:srgbClr val="567F8D"/>
                 </a:solidFill>
                 <a:latin typeface="Roboto"/>
               </a:rPr>
-              <a:t>One namespace per cluster</a:t>
-            </a:r>
-          </a:p>
-        </p:txBody>
-      </p:sp>
-      <p:cxnSp>
-        <p:nvCxnSpPr>
-          <p:cNvPr id="23" name="Connector 22"/>
-          <p:cNvCxnSpPr/>
-          <p:nvPr/>
-        </p:nvCxnSpPr>
-        <p:spPr>
-          <a:xfrm>
-            <a:off x="365760" y="5440680"/>
-            <a:ext cx="11460175" cy="0"/>
-          </a:xfrm>
-          <a:prstGeom prst="line">
-            <a:avLst/>
-          </a:prstGeom>
-          <a:ln w="12700">
-            <a:solidFill>
-              <a:srgbClr val="A8C2CA"/>
-            </a:solidFill>
-          </a:ln>
-          <a:effectLst/>
-        </p:spPr>
-        <p:style>
-          <a:lnRef idx="2">
-            <a:schemeClr val="accent1"/>
-          </a:lnRef>
-          <a:fillRef idx="0">
-            <a:schemeClr val="accent1"/>
-          </a:fillRef>
-          <a:effectRef idx="1">
-            <a:schemeClr val="accent1"/>
-          </a:effectRef>
-          <a:fontRef idx="minor">
-            <a:schemeClr val="tx1"/>
-          </a:fontRef>
-        </p:style>
-      </p:cxnSp>
-      <p:sp>
-        <p:nvSpPr>
-          <p:cNvPr id="24" name="TextBox 23"/>
-          <p:cNvSpPr txBox="1"/>
-          <p:nvPr/>
-        </p:nvSpPr>
-        <p:spPr>
-          <a:xfrm>
-            <a:off x="365760" y="5559552"/>
-            <a:ext cx="5501487" cy="566928"/>
-          </a:xfrm>
-          <a:prstGeom prst="rect">
-            <a:avLst/>
-          </a:prstGeom>
-          <a:noFill/>
-        </p:spPr>
-        <p:txBody>
-          <a:bodyPr wrap="square" anchor="t" lIns="0" rIns="0" tIns="0" bIns="0">
-            <a:spAutoFit/>
-          </a:bodyPr>
-          <a:lstStyle/>
-          <a:p>
-            <a:pPr algn="l">
-              <a:lnSpc>
-                <a:spcPct val="100000"/>
-              </a:lnSpc>
-            </a:pPr>
-            <a:r>
-              <a:rPr sz="1300" b="0" i="0">
-                <a:solidFill>
-                  <a:srgbClr val="28495A"/>
-                </a:solidFill>
-                <a:latin typeface="Roboto"/>
-              </a:rPr>
-              <a:t>Join key: query_id</a:t>
-            </a:r>
-          </a:p>
-        </p:txBody>
-      </p:sp>
-      <p:sp>
-        <p:nvSpPr>
-          <p:cNvPr id="25" name="TextBox 24"/>
-          <p:cNvSpPr txBox="1"/>
-          <p:nvPr/>
-        </p:nvSpPr>
-        <p:spPr>
-          <a:xfrm>
-            <a:off x="6324447" y="5559552"/>
-            <a:ext cx="5501487" cy="566928"/>
-          </a:xfrm>
-          <a:prstGeom prst="rect">
-            <a:avLst/>
-          </a:prstGeom>
-          <a:noFill/>
-        </p:spPr>
-        <p:txBody>
-          <a:bodyPr wrap="square" anchor="t" lIns="0" rIns="0" tIns="0" bIns="0">
-            <a:spAutoFit/>
-          </a:bodyPr>
-          <a:lstStyle/>
-          <a:p>
-            <a:pPr algn="l">
-              <a:lnSpc>
-                <a:spcPct val="100000"/>
-              </a:lnSpc>
-            </a:pPr>
-            <a:r>
-              <a:rPr sz="1300" b="0" i="0">
-                <a:solidFill>
-                  <a:srgbClr val="28495A"/>
-                </a:solidFill>
-                <a:latin typeface="Roboto"/>
-              </a:rPr>
-              <a:t>Why ClickHouse: columnar, cheap to keep, fast to query.</a:t>
-            </a:r>
-          </a:p>
-        </p:txBody>
-      </p:sp>
-      <p:pic>
-        <p:nvPicPr>
-          <p:cNvPr id="26" name="Picture 25" descr="edb_postgres_ai_lightmode.png"/>
-          <p:cNvPicPr>
-            <a:picLocks noChangeAspect="1"/>
-          </p:cNvPicPr>
-          <p:nvPr/>
-        </p:nvPicPr>
-        <p:blipFill>
-          <a:blip r:embed="rId2"/>
-          <a:stretch>
-            <a:fillRect/>
-          </a:stretch>
-        </p:blipFill>
-        <p:spPr>
-          <a:xfrm>
-            <a:off x="256032" y="6419088"/>
-            <a:ext cx="877824" cy="201168"/>
-          </a:xfrm>
-          <a:prstGeom prst="rect">
-            <a:avLst/>
-          </a:prstGeom>
-        </p:spPr>
-      </p:pic>
-      <p:sp>
-        <p:nvSpPr>
-          <p:cNvPr id="27" name="TextBox 26"/>
-          <p:cNvSpPr txBox="1"/>
-          <p:nvPr/>
-        </p:nvSpPr>
-        <p:spPr>
-          <a:xfrm>
-            <a:off x="8259775" y="6437376"/>
-            <a:ext cx="3657600" cy="182880"/>
-          </a:xfrm>
-          <a:prstGeom prst="rect">
-            <a:avLst/>
-          </a:prstGeom>
-          <a:noFill/>
-        </p:spPr>
-        <p:txBody>
-          <a:bodyPr wrap="square" anchor="t" lIns="0" rIns="0" tIns="0" bIns="0">
-            <a:spAutoFit/>
-          </a:bodyPr>
-          <a:lstStyle/>
-          <a:p>
-            <a:pPr algn="r">
-              <a:lnSpc>
-                <a:spcPct val="100000"/>
-              </a:lnSpc>
-            </a:pPr>
-            <a:r>
-              <a:rPr sz="750" b="0" i="0">
-                <a:solidFill>
-                  <a:srgbClr val="567F8D"/>
-                </a:solidFill>
-                <a:latin typeface="Roboto"/>
-              </a:rPr>
-              <a:t>©EDB 2026 — ALL RIGHTS RESERVED.</a:t>
+              <a:t>SQL</a:t>
             </a:r>
           </a:p>
         </p:txBody>

</xml_diff>